<commit_message>
Fix BigInt salt precision, add slide numbers
- generate-inputs.js: use a BigInt literal for the salt, BigInt(<number>) lost
  precision above 2^53; regenerate inputs.json
- Deck: slide numbers (n/13), mkdir before circom --output on the compile slide

Co-Authored-By: Claude Opus 5.5 <noreply@anthropic.com>
</commit_message>
<xml_diff>
--- a/circom-snarkjs/ZKP MA - Circom i snarkjs.pptx
+++ b/circom-snarkjs/ZKP MA - Circom i snarkjs.pptx
@@ -11578,6 +11578,54 @@
           </a:ln>
         </p:spPr>
       </p:pic>
+      <p:sp>
+        <p:nvSpPr>
+          <p:cNvPr id="137" name="Slide number"/>
+          <p:cNvSpPr txBox="1"/>
+          <p:nvPr/>
+        </p:nvSpPr>
+        <p:spPr>
+          <a:xfrm>
+            <a:off x="7863840" y="4754880"/>
+            <a:ext cx="1005840" cy="274320"/>
+          </a:xfrm>
+          <a:prstGeom prst="rect">
+            <a:avLst/>
+          </a:prstGeom>
+          <a:noFill/>
+        </p:spPr>
+        <p:txBody>
+          <a:bodyPr wrap="square" anchor="ctr" lIns="0" rIns="0" tIns="0" bIns="0">
+            <a:spAutoFit/>
+          </a:bodyPr>
+          <a:lstStyle/>
+          <a:p>
+            <a:pPr algn="r"/>
+            <a:fld id="{B6F15528-21DE-4FAA-801E-634DDDAF4B2B}" type="slidenum">
+              <a:rPr sz="1000" b="0" i="0">
+                <a:solidFill>
+                  <a:srgbClr val="44546A"/>
+                </a:solidFill>
+                <a:latin typeface="Rubik"/>
+                <a:ea typeface="Rubik"/>
+                <a:cs typeface="Rubik"/>
+              </a:rPr>
+              <a:t>1</a:t>
+            </a:fld>
+            <a:r>
+              <a:rPr sz="1000" b="0" i="0">
+                <a:solidFill>
+                  <a:srgbClr val="44546A"/>
+                </a:solidFill>
+                <a:latin typeface="Rubik"/>
+                <a:ea typeface="Rubik"/>
+                <a:cs typeface="Rubik"/>
+              </a:rPr>
+              <a:t>/13</a:t>
+            </a:r>
+          </a:p>
+        </p:txBody>
+      </p:sp>
     </p:spTree>
   </p:cSld>
   <p:clrMapOvr>
@@ -12283,6 +12331,54 @@
               <a:t>PLONK vs Groth16</a:t>
             </a:r>
             <a:endParaRPr/>
+          </a:p>
+        </p:txBody>
+      </p:sp>
+      <p:sp>
+        <p:nvSpPr>
+          <p:cNvPr id="156" name="Slide number"/>
+          <p:cNvSpPr txBox="1"/>
+          <p:nvPr/>
+        </p:nvSpPr>
+        <p:spPr>
+          <a:xfrm>
+            <a:off x="7863840" y="4754880"/>
+            <a:ext cx="1005840" cy="274320"/>
+          </a:xfrm>
+          <a:prstGeom prst="rect">
+            <a:avLst/>
+          </a:prstGeom>
+          <a:noFill/>
+        </p:spPr>
+        <p:txBody>
+          <a:bodyPr wrap="square" anchor="ctr" lIns="0" rIns="0" tIns="0" bIns="0">
+            <a:spAutoFit/>
+          </a:bodyPr>
+          <a:lstStyle/>
+          <a:p>
+            <a:pPr algn="r"/>
+            <a:fld id="{B6F15528-21DE-4FAA-801E-634DDDAF4B2B}" type="slidenum">
+              <a:rPr sz="1000" b="0" i="0">
+                <a:solidFill>
+                  <a:srgbClr val="44546A"/>
+                </a:solidFill>
+                <a:latin typeface="Rubik"/>
+                <a:ea typeface="Rubik"/>
+                <a:cs typeface="Rubik"/>
+              </a:rPr>
+              <a:t>2</a:t>
+            </a:fld>
+            <a:r>
+              <a:rPr sz="1000" b="0" i="0">
+                <a:solidFill>
+                  <a:srgbClr val="44546A"/>
+                </a:solidFill>
+                <a:latin typeface="Rubik"/>
+                <a:ea typeface="Rubik"/>
+                <a:cs typeface="Rubik"/>
+              </a:rPr>
+              <a:t>/13</a:t>
+            </a:r>
           </a:p>
         </p:txBody>
       </p:sp>
@@ -12405,6 +12501,54 @@
           </a:p>
         </p:txBody>
       </p:sp>
+      <p:sp>
+        <p:nvSpPr>
+          <p:cNvPr id="631" name="Slide number"/>
+          <p:cNvSpPr txBox="1"/>
+          <p:nvPr/>
+        </p:nvSpPr>
+        <p:spPr>
+          <a:xfrm>
+            <a:off x="7863840" y="4754880"/>
+            <a:ext cx="1005840" cy="274320"/>
+          </a:xfrm>
+          <a:prstGeom prst="rect">
+            <a:avLst/>
+          </a:prstGeom>
+          <a:noFill/>
+        </p:spPr>
+        <p:txBody>
+          <a:bodyPr wrap="square" anchor="ctr" lIns="0" rIns="0" tIns="0" bIns="0">
+            <a:spAutoFit/>
+          </a:bodyPr>
+          <a:lstStyle/>
+          <a:p>
+            <a:pPr algn="r"/>
+            <a:fld id="{B6F15528-21DE-4FAA-801E-634DDDAF4B2B}" type="slidenum">
+              <a:rPr sz="1000" b="0" i="0">
+                <a:solidFill>
+                  <a:srgbClr val="44546A"/>
+                </a:solidFill>
+                <a:latin typeface="Rubik"/>
+                <a:ea typeface="Rubik"/>
+                <a:cs typeface="Rubik"/>
+              </a:rPr>
+              <a:t>13</a:t>
+            </a:fld>
+            <a:r>
+              <a:rPr sz="1000" b="0" i="0">
+                <a:solidFill>
+                  <a:srgbClr val="44546A"/>
+                </a:solidFill>
+                <a:latin typeface="Rubik"/>
+                <a:ea typeface="Rubik"/>
+                <a:cs typeface="Rubik"/>
+              </a:rPr>
+              <a:t>/13</a:t>
+            </a:r>
+          </a:p>
+        </p:txBody>
+      </p:sp>
     </p:spTree>
   </p:cSld>
   <p:clrMapOvr>
@@ -14448,6 +14592,54 @@
                 <a:hlinkClick r:id="rId3"/>
               </a:rPr>
               <a:t>Full guide</a:t>
+            </a:r>
+          </a:p>
+        </p:txBody>
+      </p:sp>
+      <p:sp>
+        <p:nvSpPr>
+          <p:cNvPr id="613" name="Slide number"/>
+          <p:cNvSpPr txBox="1"/>
+          <p:nvPr/>
+        </p:nvSpPr>
+        <p:spPr>
+          <a:xfrm>
+            <a:off x="7863840" y="4754880"/>
+            <a:ext cx="1005840" cy="274320"/>
+          </a:xfrm>
+          <a:prstGeom prst="rect">
+            <a:avLst/>
+          </a:prstGeom>
+          <a:noFill/>
+        </p:spPr>
+        <p:txBody>
+          <a:bodyPr wrap="square" anchor="ctr" lIns="0" rIns="0" tIns="0" bIns="0">
+            <a:spAutoFit/>
+          </a:bodyPr>
+          <a:lstStyle/>
+          <a:p>
+            <a:pPr algn="r"/>
+            <a:fld id="{B6F15528-21DE-4FAA-801E-634DDDAF4B2B}" type="slidenum">
+              <a:rPr sz="1000" b="0" i="0">
+                <a:solidFill>
+                  <a:srgbClr val="44546A"/>
+                </a:solidFill>
+                <a:latin typeface="Rubik"/>
+                <a:ea typeface="Rubik"/>
+                <a:cs typeface="Rubik"/>
+              </a:rPr>
+              <a:t>3</a:t>
+            </a:fld>
+            <a:r>
+              <a:rPr sz="1000" b="0" i="0">
+                <a:solidFill>
+                  <a:srgbClr val="44546A"/>
+                </a:solidFill>
+                <a:latin typeface="Rubik"/>
+                <a:ea typeface="Rubik"/>
+                <a:cs typeface="Rubik"/>
+              </a:rPr>
+              <a:t>/13</a:t>
             </a:r>
           </a:p>
         </p:txBody>
@@ -16181,6 +16373,54 @@
           </a:p>
         </p:txBody>
       </p:sp>
+      <p:sp>
+        <p:nvSpPr>
+          <p:cNvPr id="613" name="Slide number"/>
+          <p:cNvSpPr txBox="1"/>
+          <p:nvPr/>
+        </p:nvSpPr>
+        <p:spPr>
+          <a:xfrm>
+            <a:off x="7863840" y="4754880"/>
+            <a:ext cx="1005840" cy="274320"/>
+          </a:xfrm>
+          <a:prstGeom prst="rect">
+            <a:avLst/>
+          </a:prstGeom>
+          <a:noFill/>
+        </p:spPr>
+        <p:txBody>
+          <a:bodyPr wrap="square" anchor="ctr" lIns="0" rIns="0" tIns="0" bIns="0">
+            <a:spAutoFit/>
+          </a:bodyPr>
+          <a:lstStyle/>
+          <a:p>
+            <a:pPr algn="r"/>
+            <a:fld id="{B6F15528-21DE-4FAA-801E-634DDDAF4B2B}" type="slidenum">
+              <a:rPr sz="1000" b="0" i="0">
+                <a:solidFill>
+                  <a:srgbClr val="44546A"/>
+                </a:solidFill>
+                <a:latin typeface="Rubik"/>
+                <a:ea typeface="Rubik"/>
+                <a:cs typeface="Rubik"/>
+              </a:rPr>
+              <a:t>4</a:t>
+            </a:fld>
+            <a:r>
+              <a:rPr sz="1000" b="0" i="0">
+                <a:solidFill>
+                  <a:srgbClr val="44546A"/>
+                </a:solidFill>
+                <a:latin typeface="Rubik"/>
+                <a:ea typeface="Rubik"/>
+                <a:cs typeface="Rubik"/>
+              </a:rPr>
+              <a:t>/13</a:t>
+            </a:r>
+          </a:p>
+        </p:txBody>
+      </p:sp>
     </p:spTree>
   </p:cSld>
   <p:clrMapOvr>
@@ -17647,6 +17887,54 @@
                 <a:cs typeface="Rubik"/>
               </a:rPr>
               <a:t>Setup produces proving/verification keys. Prover uses .zkey + witness; verifier needs only the vkey and public signals.</a:t>
+            </a:r>
+          </a:p>
+        </p:txBody>
+      </p:sp>
+      <p:sp>
+        <p:nvSpPr>
+          <p:cNvPr id="619" name="Slide number"/>
+          <p:cNvSpPr txBox="1"/>
+          <p:nvPr/>
+        </p:nvSpPr>
+        <p:spPr>
+          <a:xfrm>
+            <a:off x="7863840" y="4754880"/>
+            <a:ext cx="1005840" cy="274320"/>
+          </a:xfrm>
+          <a:prstGeom prst="rect">
+            <a:avLst/>
+          </a:prstGeom>
+          <a:noFill/>
+        </p:spPr>
+        <p:txBody>
+          <a:bodyPr wrap="square" anchor="ctr" lIns="0" rIns="0" tIns="0" bIns="0">
+            <a:spAutoFit/>
+          </a:bodyPr>
+          <a:lstStyle/>
+          <a:p>
+            <a:pPr algn="r"/>
+            <a:fld id="{B6F15528-21DE-4FAA-801E-634DDDAF4B2B}" type="slidenum">
+              <a:rPr sz="1000" b="0" i="0">
+                <a:solidFill>
+                  <a:srgbClr val="44546A"/>
+                </a:solidFill>
+                <a:latin typeface="Rubik"/>
+                <a:ea typeface="Rubik"/>
+                <a:cs typeface="Rubik"/>
+              </a:rPr>
+              <a:t>5</a:t>
+            </a:fld>
+            <a:r>
+              <a:rPr sz="1000" b="0" i="0">
+                <a:solidFill>
+                  <a:srgbClr val="44546A"/>
+                </a:solidFill>
+                <a:latin typeface="Rubik"/>
+                <a:ea typeface="Rubik"/>
+                <a:cs typeface="Rubik"/>
+              </a:rPr>
+              <a:t>/13</a:t>
             </a:r>
           </a:p>
         </p:txBody>
@@ -20260,6 +20548,54 @@
           </a:p>
         </p:txBody>
       </p:sp>
+      <p:sp>
+        <p:nvSpPr>
+          <p:cNvPr id="603" name="Slide number"/>
+          <p:cNvSpPr txBox="1"/>
+          <p:nvPr/>
+        </p:nvSpPr>
+        <p:spPr>
+          <a:xfrm>
+            <a:off x="7863840" y="4754880"/>
+            <a:ext cx="1005840" cy="274320"/>
+          </a:xfrm>
+          <a:prstGeom prst="rect">
+            <a:avLst/>
+          </a:prstGeom>
+          <a:noFill/>
+        </p:spPr>
+        <p:txBody>
+          <a:bodyPr wrap="square" anchor="ctr" lIns="0" rIns="0" tIns="0" bIns="0">
+            <a:spAutoFit/>
+          </a:bodyPr>
+          <a:lstStyle/>
+          <a:p>
+            <a:pPr algn="r"/>
+            <a:fld id="{B6F15528-21DE-4FAA-801E-634DDDAF4B2B}" type="slidenum">
+              <a:rPr sz="1000" b="0" i="0">
+                <a:solidFill>
+                  <a:srgbClr val="44546A"/>
+                </a:solidFill>
+                <a:latin typeface="Rubik"/>
+                <a:ea typeface="Rubik"/>
+                <a:cs typeface="Rubik"/>
+              </a:rPr>
+              <a:t>6</a:t>
+            </a:fld>
+            <a:r>
+              <a:rPr sz="1000" b="0" i="0">
+                <a:solidFill>
+                  <a:srgbClr val="44546A"/>
+                </a:solidFill>
+                <a:latin typeface="Rubik"/>
+                <a:ea typeface="Rubik"/>
+                <a:cs typeface="Rubik"/>
+              </a:rPr>
+              <a:t>/13</a:t>
+            </a:r>
+          </a:p>
+        </p:txBody>
+      </p:sp>
     </p:spTree>
   </p:cSld>
   <p:clrMapOvr>
@@ -21085,6 +21421,116 @@
                 <a:ea typeface="Courier New"/>
                 <a:cs typeface="Courier New"/>
               </a:rPr>
+              <a:t>mkdir</a:t>
+            </a:r>
+            <a:r>
+              <a:rPr sz="1098" b="0" i="0">
+                <a:solidFill>
+                  <a:srgbClr val="06182C"/>
+                </a:solidFill>
+                <a:latin typeface="Courier New"/>
+                <a:ea typeface="Courier New"/>
+                <a:cs typeface="Courier New"/>
+              </a:rPr>
+              <a:t> </a:t>
+            </a:r>
+            <a:r>
+              <a:rPr sz="1098" b="0" i="0">
+                <a:solidFill>
+                  <a:srgbClr val="06182C"/>
+                </a:solidFill>
+                <a:latin typeface="Courier New"/>
+                <a:ea typeface="Courier New"/>
+                <a:cs typeface="Courier New"/>
+              </a:rPr>
+              <a:t>-</a:t>
+            </a:r>
+            <a:r>
+              <a:rPr sz="1098" b="0" i="0">
+                <a:solidFill>
+                  <a:srgbClr val="06182C"/>
+                </a:solidFill>
+                <a:latin typeface="Courier New"/>
+                <a:ea typeface="Courier New"/>
+                <a:cs typeface="Courier New"/>
+              </a:rPr>
+              <a:t>p</a:t>
+            </a:r>
+            <a:r>
+              <a:rPr sz="1098" b="0" i="0">
+                <a:solidFill>
+                  <a:srgbClr val="06182C"/>
+                </a:solidFill>
+                <a:latin typeface="Courier New"/>
+                <a:ea typeface="Courier New"/>
+                <a:cs typeface="Courier New"/>
+              </a:rPr>
+              <a:t> </a:t>
+            </a:r>
+            <a:r>
+              <a:rPr sz="1098" b="0" i="0">
+                <a:solidFill>
+                  <a:srgbClr val="06182C"/>
+                </a:solidFill>
+                <a:latin typeface="Courier New"/>
+                <a:ea typeface="Courier New"/>
+                <a:cs typeface="Courier New"/>
+              </a:rPr>
+              <a:t>artifacts</a:t>
+            </a:r>
+            <a:r>
+              <a:rPr sz="1098" b="0" i="0">
+                <a:solidFill>
+                  <a:srgbClr val="06182C"/>
+                </a:solidFill>
+                <a:latin typeface="Courier New"/>
+                <a:ea typeface="Courier New"/>
+                <a:cs typeface="Courier New"/>
+              </a:rPr>
+              <a:t> </a:t>
+            </a:r>
+            <a:r>
+              <a:rPr sz="1098" b="0" i="0">
+                <a:solidFill>
+                  <a:srgbClr val="06182C"/>
+                </a:solidFill>
+                <a:latin typeface="Courier New"/>
+                <a:ea typeface="Courier New"/>
+                <a:cs typeface="Courier New"/>
+              </a:rPr>
+              <a:t>&amp;</a:t>
+            </a:r>
+            <a:r>
+              <a:rPr sz="1098" b="0" i="0">
+                <a:solidFill>
+                  <a:srgbClr val="06182C"/>
+                </a:solidFill>
+                <a:latin typeface="Courier New"/>
+                <a:ea typeface="Courier New"/>
+                <a:cs typeface="Courier New"/>
+              </a:rPr>
+              <a:t>&amp;</a:t>
+            </a:r>
+            <a:r>
+              <a:rPr sz="1098" b="0" i="0">
+                <a:solidFill>
+                  <a:srgbClr val="06182C"/>
+                </a:solidFill>
+                <a:latin typeface="Courier New"/>
+                <a:ea typeface="Courier New"/>
+                <a:cs typeface="Courier New"/>
+              </a:rPr>
+              <a:t> </a:t>
+            </a:r>
+            <a:r>
+              <a:rPr sz="1098" b="1" i="0">
+                <a:solidFill>
+                  <a:srgbClr val="1B5EC9"/>
+                </a:solidFill>
+                <a:latin typeface="Courier New"/>
+                <a:ea typeface="Courier New"/>
+                <a:cs typeface="Courier New"/>
+              </a:rPr>
               <a:t>circom</a:t>
             </a:r>
             <a:r>
@@ -21769,6 +22215,54 @@
                 <a:cs typeface="Courier New"/>
               </a:rPr>
               <a:t>wtns</a:t>
+            </a:r>
+          </a:p>
+        </p:txBody>
+      </p:sp>
+      <p:sp>
+        <p:nvSpPr>
+          <p:cNvPr id="608" name="Slide number"/>
+          <p:cNvSpPr txBox="1"/>
+          <p:nvPr/>
+        </p:nvSpPr>
+        <p:spPr>
+          <a:xfrm>
+            <a:off x="7863840" y="4754880"/>
+            <a:ext cx="1005840" cy="274320"/>
+          </a:xfrm>
+          <a:prstGeom prst="rect">
+            <a:avLst/>
+          </a:prstGeom>
+          <a:noFill/>
+        </p:spPr>
+        <p:txBody>
+          <a:bodyPr wrap="square" anchor="ctr" lIns="0" rIns="0" tIns="0" bIns="0">
+            <a:spAutoFit/>
+          </a:bodyPr>
+          <a:lstStyle/>
+          <a:p>
+            <a:pPr algn="r"/>
+            <a:fld id="{B6F15528-21DE-4FAA-801E-634DDDAF4B2B}" type="slidenum">
+              <a:rPr sz="1000" b="0" i="0">
+                <a:solidFill>
+                  <a:srgbClr val="44546A"/>
+                </a:solidFill>
+                <a:latin typeface="Rubik"/>
+                <a:ea typeface="Rubik"/>
+                <a:cs typeface="Rubik"/>
+              </a:rPr>
+              <a:t>7</a:t>
+            </a:fld>
+            <a:r>
+              <a:rPr sz="1000" b="0" i="0">
+                <a:solidFill>
+                  <a:srgbClr val="44546A"/>
+                </a:solidFill>
+                <a:latin typeface="Rubik"/>
+                <a:ea typeface="Rubik"/>
+                <a:cs typeface="Rubik"/>
+              </a:rPr>
+              <a:t>/13</a:t>
             </a:r>
           </a:p>
         </p:txBody>
@@ -22887,6 +23381,54 @@
           </a:p>
         </p:txBody>
       </p:sp>
+      <p:sp>
+        <p:nvSpPr>
+          <p:cNvPr id="603" name="Slide number"/>
+          <p:cNvSpPr txBox="1"/>
+          <p:nvPr/>
+        </p:nvSpPr>
+        <p:spPr>
+          <a:xfrm>
+            <a:off x="7863840" y="4754880"/>
+            <a:ext cx="1005840" cy="274320"/>
+          </a:xfrm>
+          <a:prstGeom prst="rect">
+            <a:avLst/>
+          </a:prstGeom>
+          <a:noFill/>
+        </p:spPr>
+        <p:txBody>
+          <a:bodyPr wrap="square" anchor="ctr" lIns="0" rIns="0" tIns="0" bIns="0">
+            <a:spAutoFit/>
+          </a:bodyPr>
+          <a:lstStyle/>
+          <a:p>
+            <a:pPr algn="r"/>
+            <a:fld id="{B6F15528-21DE-4FAA-801E-634DDDAF4B2B}" type="slidenum">
+              <a:rPr sz="1000" b="0" i="0">
+                <a:solidFill>
+                  <a:srgbClr val="44546A"/>
+                </a:solidFill>
+                <a:latin typeface="Rubik"/>
+                <a:ea typeface="Rubik"/>
+                <a:cs typeface="Rubik"/>
+              </a:rPr>
+              <a:t>8</a:t>
+            </a:fld>
+            <a:r>
+              <a:rPr sz="1000" b="0" i="0">
+                <a:solidFill>
+                  <a:srgbClr val="44546A"/>
+                </a:solidFill>
+                <a:latin typeface="Rubik"/>
+                <a:ea typeface="Rubik"/>
+                <a:cs typeface="Rubik"/>
+              </a:rPr>
+              <a:t>/13</a:t>
+            </a:r>
+          </a:p>
+        </p:txBody>
+      </p:sp>
     </p:spTree>
   </p:cSld>
   <p:clrMapOvr>
@@ -24947,6 +25489,54 @@
                 <a:cs typeface="Courier New"/>
               </a:rPr>
               <a:t>json</a:t>
+            </a:r>
+          </a:p>
+        </p:txBody>
+      </p:sp>
+      <p:sp>
+        <p:nvSpPr>
+          <p:cNvPr id="612" name="Slide number"/>
+          <p:cNvSpPr txBox="1"/>
+          <p:nvPr/>
+        </p:nvSpPr>
+        <p:spPr>
+          <a:xfrm>
+            <a:off x="7863840" y="4754880"/>
+            <a:ext cx="1005840" cy="274320"/>
+          </a:xfrm>
+          <a:prstGeom prst="rect">
+            <a:avLst/>
+          </a:prstGeom>
+          <a:noFill/>
+        </p:spPr>
+        <p:txBody>
+          <a:bodyPr wrap="square" anchor="ctr" lIns="0" rIns="0" tIns="0" bIns="0">
+            <a:spAutoFit/>
+          </a:bodyPr>
+          <a:lstStyle/>
+          <a:p>
+            <a:pPr algn="r"/>
+            <a:fld id="{B6F15528-21DE-4FAA-801E-634DDDAF4B2B}" type="slidenum">
+              <a:rPr sz="1000" b="0" i="0">
+                <a:solidFill>
+                  <a:srgbClr val="44546A"/>
+                </a:solidFill>
+                <a:latin typeface="Rubik"/>
+                <a:ea typeface="Rubik"/>
+                <a:cs typeface="Rubik"/>
+              </a:rPr>
+              <a:t>9</a:t>
+            </a:fld>
+            <a:r>
+              <a:rPr sz="1000" b="0" i="0">
+                <a:solidFill>
+                  <a:srgbClr val="44546A"/>
+                </a:solidFill>
+                <a:latin typeface="Rubik"/>
+                <a:ea typeface="Rubik"/>
+                <a:cs typeface="Rubik"/>
+              </a:rPr>
+              <a:t>/13</a:t>
             </a:r>
           </a:p>
         </p:txBody>
@@ -26960,6 +27550,54 @@
           </a:p>
         </p:txBody>
       </p:sp>
+      <p:sp>
+        <p:nvSpPr>
+          <p:cNvPr id="612" name="Slide number"/>
+          <p:cNvSpPr txBox="1"/>
+          <p:nvPr/>
+        </p:nvSpPr>
+        <p:spPr>
+          <a:xfrm>
+            <a:off x="7863840" y="4754880"/>
+            <a:ext cx="1005840" cy="274320"/>
+          </a:xfrm>
+          <a:prstGeom prst="rect">
+            <a:avLst/>
+          </a:prstGeom>
+          <a:noFill/>
+        </p:spPr>
+        <p:txBody>
+          <a:bodyPr wrap="square" anchor="ctr" lIns="0" rIns="0" tIns="0" bIns="0">
+            <a:spAutoFit/>
+          </a:bodyPr>
+          <a:lstStyle/>
+          <a:p>
+            <a:pPr algn="r"/>
+            <a:fld id="{B6F15528-21DE-4FAA-801E-634DDDAF4B2B}" type="slidenum">
+              <a:rPr sz="1000" b="0" i="0">
+                <a:solidFill>
+                  <a:srgbClr val="44546A"/>
+                </a:solidFill>
+                <a:latin typeface="Rubik"/>
+                <a:ea typeface="Rubik"/>
+                <a:cs typeface="Rubik"/>
+              </a:rPr>
+              <a:t>10</a:t>
+            </a:fld>
+            <a:r>
+              <a:rPr sz="1000" b="0" i="0">
+                <a:solidFill>
+                  <a:srgbClr val="44546A"/>
+                </a:solidFill>
+                <a:latin typeface="Rubik"/>
+                <a:ea typeface="Rubik"/>
+                <a:cs typeface="Rubik"/>
+              </a:rPr>
+              <a:t>/13</a:t>
+            </a:r>
+          </a:p>
+        </p:txBody>
+      </p:sp>
     </p:spTree>
   </p:cSld>
   <p:clrMapOvr>
@@ -28891,6 +29529,54 @@
                 <a:cs typeface="Rubik"/>
               </a:rPr>
               <a:t>runs in the browser: private inputs never leave the user</a:t>
+            </a:r>
+          </a:p>
+        </p:txBody>
+      </p:sp>
+      <p:sp>
+        <p:nvSpPr>
+          <p:cNvPr id="600" name="Slide number"/>
+          <p:cNvSpPr txBox="1"/>
+          <p:nvPr/>
+        </p:nvSpPr>
+        <p:spPr>
+          <a:xfrm>
+            <a:off x="7863840" y="4754880"/>
+            <a:ext cx="1005840" cy="274320"/>
+          </a:xfrm>
+          <a:prstGeom prst="rect">
+            <a:avLst/>
+          </a:prstGeom>
+          <a:noFill/>
+        </p:spPr>
+        <p:txBody>
+          <a:bodyPr wrap="square" anchor="ctr" lIns="0" rIns="0" tIns="0" bIns="0">
+            <a:spAutoFit/>
+          </a:bodyPr>
+          <a:lstStyle/>
+          <a:p>
+            <a:pPr algn="r"/>
+            <a:fld id="{B6F15528-21DE-4FAA-801E-634DDDAF4B2B}" type="slidenum">
+              <a:rPr sz="1000" b="0" i="0">
+                <a:solidFill>
+                  <a:srgbClr val="44546A"/>
+                </a:solidFill>
+                <a:latin typeface="Rubik"/>
+                <a:ea typeface="Rubik"/>
+                <a:cs typeface="Rubik"/>
+              </a:rPr>
+              <a:t>11</a:t>
+            </a:fld>
+            <a:r>
+              <a:rPr sz="1000" b="0" i="0">
+                <a:solidFill>
+                  <a:srgbClr val="44546A"/>
+                </a:solidFill>
+                <a:latin typeface="Rubik"/>
+                <a:ea typeface="Rubik"/>
+                <a:cs typeface="Rubik"/>
+              </a:rPr>
+              <a:t>/13</a:t>
             </a:r>
           </a:p>
         </p:txBody>
@@ -29996,6 +30682,54 @@
                 <a:cs typeface="Rubik"/>
               </a:rPr>
               <a:t>: many different circuits (arbitrary business logic) with reasonably fast performance.</a:t>
+            </a:r>
+          </a:p>
+        </p:txBody>
+      </p:sp>
+      <p:sp>
+        <p:nvSpPr>
+          <p:cNvPr id="615" name="Slide number"/>
+          <p:cNvSpPr txBox="1"/>
+          <p:nvPr/>
+        </p:nvSpPr>
+        <p:spPr>
+          <a:xfrm>
+            <a:off x="7863840" y="4754880"/>
+            <a:ext cx="1005840" cy="274320"/>
+          </a:xfrm>
+          <a:prstGeom prst="rect">
+            <a:avLst/>
+          </a:prstGeom>
+          <a:noFill/>
+        </p:spPr>
+        <p:txBody>
+          <a:bodyPr wrap="square" anchor="ctr" lIns="0" rIns="0" tIns="0" bIns="0">
+            <a:spAutoFit/>
+          </a:bodyPr>
+          <a:lstStyle/>
+          <a:p>
+            <a:pPr algn="r"/>
+            <a:fld id="{B6F15528-21DE-4FAA-801E-634DDDAF4B2B}" type="slidenum">
+              <a:rPr sz="1000" b="0" i="0">
+                <a:solidFill>
+                  <a:srgbClr val="44546A"/>
+                </a:solidFill>
+                <a:latin typeface="Rubik"/>
+                <a:ea typeface="Rubik"/>
+                <a:cs typeface="Rubik"/>
+              </a:rPr>
+              <a:t>12</a:t>
+            </a:fld>
+            <a:r>
+              <a:rPr sz="1000" b="0" i="0">
+                <a:solidFill>
+                  <a:srgbClr val="44546A"/>
+                </a:solidFill>
+                <a:latin typeface="Rubik"/>
+                <a:ea typeface="Rubik"/>
+                <a:cs typeface="Rubik"/>
+              </a:rPr>
+              <a:t>/13</a:t>
             </a:r>
           </a:p>
         </p:txBody>

</xml_diff>